<commit_message>
Regenerate lock file and update season-card illustrations
- Fresh package-lock.json fixes CI 'npm ci' failure (Linux runner was
  missing @emnapi/core / @emnapi/runtime entries that only existed in
  the previous Windows-generated lock)
- Replaced four flat geometric stage SVGs on the landing page with
  miniatures of real app states: dashed ghost branch (dormant),
  tapered oak twig with end-knots (bare), branches with sparse young
  almond leaves (growth), full canopy of seeded leaves + cherry-blossom
  dabs (in bloom)
</commit_message>
<xml_diff>
--- a/SkillTree-eksam.pptx
+++ b/SkillTree-eksam.pptx
@@ -5,7 +5,7 @@
     <p:sldMasterId id="2147483648" r:id="rId1"/>
   </p:sldMasterIdLst>
   <p:notesMasterIdLst>
-    <p:notesMasterId r:id="rId12"/>
+    <p:notesMasterId r:id="rId15"/>
   </p:notesMasterIdLst>
   <p:sldIdLst>
     <p:sldId id="256" r:id="rId2"/>
@@ -16,8 +16,11 @@
     <p:sldId id="261" r:id="rId7"/>
     <p:sldId id="262" r:id="rId8"/>
     <p:sldId id="264" r:id="rId9"/>
-    <p:sldId id="265" r:id="rId10"/>
-    <p:sldId id="266" r:id="rId11"/>
+    <p:sldId id="268" r:id="rId10"/>
+    <p:sldId id="267" r:id="rId11"/>
+    <p:sldId id="269" r:id="rId12"/>
+    <p:sldId id="265" r:id="rId13"/>
+    <p:sldId id="266" r:id="rId14"/>
   </p:sldIdLst>
   <p:sldSz cx="12192000" cy="6858000"/>
   <p:notesSz cx="6858000" cy="12192000"/>
@@ -335,6 +338,114 @@
   <p:cSld>
     <p:spTree>
       <p:nvGrpSpPr>
+        <p:cNvPr id="1" name="">
+          <a:extLst>
+            <a:ext uri="{FF2B5EF4-FFF2-40B4-BE49-F238E27FC236}">
+              <a16:creationId xmlns:a16="http://schemas.microsoft.com/office/drawing/2014/main" id="{B47C3E3C-5C7C-7804-4200-E8FC0F7A295B}"/>
+            </a:ext>
+          </a:extLst>
+        </p:cNvPr>
+        <p:cNvGrpSpPr/>
+        <p:nvPr/>
+      </p:nvGrpSpPr>
+      <p:grpSpPr>
+        <a:xfrm>
+          <a:off x="0" y="0"/>
+          <a:ext cx="0" cy="0"/>
+          <a:chOff x="0" y="0"/>
+          <a:chExt cx="0" cy="0"/>
+        </a:xfrm>
+      </p:grpSpPr>
+      <p:sp>
+        <p:nvSpPr>
+          <p:cNvPr id="2" name="Slide Image Placeholder 1">
+            <a:extLst>
+              <a:ext uri="{FF2B5EF4-FFF2-40B4-BE49-F238E27FC236}">
+                <a16:creationId xmlns:a16="http://schemas.microsoft.com/office/drawing/2014/main" id="{8F00B90B-912E-8729-41C4-DE22E830C4B4}"/>
+              </a:ext>
+            </a:extLst>
+          </p:cNvPr>
+          <p:cNvSpPr>
+            <a:spLocks noGrp="1" noRot="1" noChangeAspect="1"/>
+          </p:cNvSpPr>
+          <p:nvPr>
+            <p:ph type="sldImg"/>
+          </p:nvPr>
+        </p:nvSpPr>
+        <p:spPr/>
+      </p:sp>
+      <p:sp>
+        <p:nvSpPr>
+          <p:cNvPr id="3" name="Notes Placeholder 2">
+            <a:extLst>
+              <a:ext uri="{FF2B5EF4-FFF2-40B4-BE49-F238E27FC236}">
+                <a16:creationId xmlns:a16="http://schemas.microsoft.com/office/drawing/2014/main" id="{F852FC50-EDDF-ACA8-14DE-8D8C3BFCC236}"/>
+              </a:ext>
+            </a:extLst>
+          </p:cNvPr>
+          <p:cNvSpPr>
+            <a:spLocks noGrp="1"/>
+          </p:cNvSpPr>
+          <p:nvPr>
+            <p:ph type="body" idx="1"/>
+          </p:nvPr>
+        </p:nvSpPr>
+        <p:spPr/>
+        <p:txBody>
+          <a:bodyPr/>
+          <a:lstStyle/>
+          <a:p>
+            <a:endParaRPr lang="en-US" dirty="0"/>
+          </a:p>
+        </p:txBody>
+      </p:sp>
+      <p:sp>
+        <p:nvSpPr>
+          <p:cNvPr id="4" name="Slide Number Placeholder 3">
+            <a:extLst>
+              <a:ext uri="{FF2B5EF4-FFF2-40B4-BE49-F238E27FC236}">
+                <a16:creationId xmlns:a16="http://schemas.microsoft.com/office/drawing/2014/main" id="{EBE45D66-BF56-E420-57F1-5B4CDC7591D1}"/>
+              </a:ext>
+            </a:extLst>
+          </p:cNvPr>
+          <p:cNvSpPr>
+            <a:spLocks noGrp="1"/>
+          </p:cNvSpPr>
+          <p:nvPr>
+            <p:ph type="sldNum" sz="quarter" idx="10"/>
+          </p:nvPr>
+        </p:nvSpPr>
+        <p:spPr/>
+        <p:txBody>
+          <a:bodyPr/>
+          <a:lstStyle/>
+          <a:p>
+            <a:fld id="{F7021451-1387-4CA6-816F-3879F97B5CBC}" type="slidenum">
+              <a:rPr lang="en-US"/>
+              <a:t>10</a:t>
+            </a:fld>
+            <a:endParaRPr lang="en-US"/>
+          </a:p>
+        </p:txBody>
+      </p:sp>
+    </p:spTree>
+    <p:extLst>
+      <p:ext uri="{BB962C8B-B14F-4D97-AF65-F5344CB8AC3E}">
+        <p14:creationId xmlns:p14="http://schemas.microsoft.com/office/powerpoint/2010/main" val="2727936823"/>
+      </p:ext>
+    </p:extLst>
+  </p:cSld>
+  <p:clrMapOvr>
+    <a:masterClrMapping/>
+  </p:clrMapOvr>
+</p:notes>
+</file>
+
+<file path=ppt/notesSlides/notesSlide11.xml><?xml version="1.0" encoding="utf-8"?>
+<p:notes xmlns:a="http://schemas.openxmlformats.org/drawingml/2006/main" xmlns:r="http://schemas.openxmlformats.org/officeDocument/2006/relationships" xmlns:p="http://schemas.openxmlformats.org/presentationml/2006/main">
+  <p:cSld>
+    <p:spTree>
+      <p:nvGrpSpPr>
         <p:cNvPr id="1" name=""/>
         <p:cNvGrpSpPr/>
         <p:nvPr/>
@@ -395,7 +506,91 @@
           <a:p>
             <a:fld id="{F7021451-1387-4CA6-816F-3879F97B5CBC}" type="slidenum">
               <a:rPr lang="en-US"/>
-              <a:t>10</a:t>
+              <a:t>12</a:t>
+            </a:fld>
+            <a:endParaRPr lang="en-US"/>
+          </a:p>
+        </p:txBody>
+      </p:sp>
+    </p:spTree>
+    <p:extLst>
+      <p:ext uri="{BB962C8B-B14F-4D97-AF65-F5344CB8AC3E}">
+        <p14:creationId xmlns:p14="http://schemas.microsoft.com/office/powerpoint/2010/main" val="1024086991"/>
+      </p:ext>
+    </p:extLst>
+  </p:cSld>
+  <p:clrMapOvr>
+    <a:masterClrMapping/>
+  </p:clrMapOvr>
+</p:notes>
+</file>
+
+<file path=ppt/notesSlides/notesSlide12.xml><?xml version="1.0" encoding="utf-8"?>
+<p:notes xmlns:a="http://schemas.openxmlformats.org/drawingml/2006/main" xmlns:r="http://schemas.openxmlformats.org/officeDocument/2006/relationships" xmlns:p="http://schemas.openxmlformats.org/presentationml/2006/main">
+  <p:cSld>
+    <p:spTree>
+      <p:nvGrpSpPr>
+        <p:cNvPr id="1" name=""/>
+        <p:cNvGrpSpPr/>
+        <p:nvPr/>
+      </p:nvGrpSpPr>
+      <p:grpSpPr>
+        <a:xfrm>
+          <a:off x="0" y="0"/>
+          <a:ext cx="0" cy="0"/>
+          <a:chOff x="0" y="0"/>
+          <a:chExt cx="0" cy="0"/>
+        </a:xfrm>
+      </p:grpSpPr>
+      <p:sp>
+        <p:nvSpPr>
+          <p:cNvPr id="2" name="Slide Image Placeholder 1"/>
+          <p:cNvSpPr>
+            <a:spLocks noGrp="1" noRot="1" noChangeAspect="1"/>
+          </p:cNvSpPr>
+          <p:nvPr>
+            <p:ph type="sldImg"/>
+          </p:nvPr>
+        </p:nvSpPr>
+        <p:spPr/>
+      </p:sp>
+      <p:sp>
+        <p:nvSpPr>
+          <p:cNvPr id="3" name="Notes Placeholder 2"/>
+          <p:cNvSpPr>
+            <a:spLocks noGrp="1"/>
+          </p:cNvSpPr>
+          <p:nvPr>
+            <p:ph type="body" idx="1"/>
+          </p:nvPr>
+        </p:nvSpPr>
+        <p:spPr/>
+        <p:txBody>
+          <a:bodyPr/>
+          <a:lstStyle/>
+          <a:p>
+            <a:endParaRPr lang="en-US" dirty="0"/>
+          </a:p>
+        </p:txBody>
+      </p:sp>
+      <p:sp>
+        <p:nvSpPr>
+          <p:cNvPr id="4" name="Slide Number Placeholder 3"/>
+          <p:cNvSpPr>
+            <a:spLocks noGrp="1"/>
+          </p:cNvSpPr>
+          <p:nvPr>
+            <p:ph type="sldNum" sz="quarter" idx="10"/>
+          </p:nvPr>
+        </p:nvSpPr>
+        <p:spPr/>
+        <p:txBody>
+          <a:bodyPr/>
+          <a:lstStyle/>
+          <a:p>
+            <a:fld id="{F7021451-1387-4CA6-816F-3879F97B5CBC}" type="slidenum">
+              <a:rPr lang="en-US"/>
+              <a:t>13</a:t>
             </a:fld>
             <a:endParaRPr lang="en-US"/>
           </a:p>
@@ -1007,7 +1202,13 @@
   <p:cSld>
     <p:spTree>
       <p:nvGrpSpPr>
-        <p:cNvPr id="1" name=""/>
+        <p:cNvPr id="1" name="">
+          <a:extLst>
+            <a:ext uri="{FF2B5EF4-FFF2-40B4-BE49-F238E27FC236}">
+              <a16:creationId xmlns:a16="http://schemas.microsoft.com/office/drawing/2014/main" id="{C4EC7871-DE20-F414-9C1B-67B9FDD76213}"/>
+            </a:ext>
+          </a:extLst>
+        </p:cNvPr>
         <p:cNvGrpSpPr/>
         <p:nvPr/>
       </p:nvGrpSpPr>
@@ -1021,7 +1222,13 @@
       </p:grpSpPr>
       <p:sp>
         <p:nvSpPr>
-          <p:cNvPr id="2" name="Slide Image Placeholder 1"/>
+          <p:cNvPr id="2" name="Slide Image Placeholder 1">
+            <a:extLst>
+              <a:ext uri="{FF2B5EF4-FFF2-40B4-BE49-F238E27FC236}">
+                <a16:creationId xmlns:a16="http://schemas.microsoft.com/office/drawing/2014/main" id="{A52E3A13-0E3F-76C0-8CEB-32F37A4E1DE7}"/>
+              </a:ext>
+            </a:extLst>
+          </p:cNvPr>
           <p:cNvSpPr>
             <a:spLocks noGrp="1" noRot="1" noChangeAspect="1"/>
           </p:cNvSpPr>
@@ -1033,7 +1240,13 @@
       </p:sp>
       <p:sp>
         <p:nvSpPr>
-          <p:cNvPr id="3" name="Notes Placeholder 2"/>
+          <p:cNvPr id="3" name="Notes Placeholder 2">
+            <a:extLst>
+              <a:ext uri="{FF2B5EF4-FFF2-40B4-BE49-F238E27FC236}">
+                <a16:creationId xmlns:a16="http://schemas.microsoft.com/office/drawing/2014/main" id="{DBBB4E07-2AAF-7F77-F763-442EA26E1B25}"/>
+              </a:ext>
+            </a:extLst>
+          </p:cNvPr>
           <p:cNvSpPr>
             <a:spLocks noGrp="1"/>
           </p:cNvSpPr>
@@ -1052,7 +1265,13 @@
       </p:sp>
       <p:sp>
         <p:nvSpPr>
-          <p:cNvPr id="4" name="Slide Number Placeholder 3"/>
+          <p:cNvPr id="4" name="Slide Number Placeholder 3">
+            <a:extLst>
+              <a:ext uri="{FF2B5EF4-FFF2-40B4-BE49-F238E27FC236}">
+                <a16:creationId xmlns:a16="http://schemas.microsoft.com/office/drawing/2014/main" id="{B3E4C7BE-129C-84C5-A006-5DC0E4753341}"/>
+              </a:ext>
+            </a:extLst>
+          </p:cNvPr>
           <p:cNvSpPr>
             <a:spLocks noGrp="1"/>
           </p:cNvSpPr>
@@ -1076,7 +1295,7 @@
     </p:spTree>
     <p:extLst>
       <p:ext uri="{BB962C8B-B14F-4D97-AF65-F5344CB8AC3E}">
-        <p14:creationId xmlns:p14="http://schemas.microsoft.com/office/powerpoint/2010/main" val="1024086991"/>
+        <p14:creationId xmlns:p14="http://schemas.microsoft.com/office/powerpoint/2010/main" val="1700104388"/>
       </p:ext>
     </p:extLst>
   </p:cSld>
@@ -1646,6 +1865,760 @@
 
 <file path=ppt/slides/slide10.xml><?xml version="1.0" encoding="utf-8"?>
 <p:sld xmlns:a="http://schemas.openxmlformats.org/drawingml/2006/main" xmlns:r="http://schemas.openxmlformats.org/officeDocument/2006/relationships" xmlns:p="http://schemas.openxmlformats.org/presentationml/2006/main">
+  <p:cSld>
+    <p:bg>
+      <p:bgPr>
+        <a:solidFill>
+          <a:srgbClr val="FAF6F0"/>
+        </a:solidFill>
+        <a:effectLst/>
+      </p:bgPr>
+    </p:bg>
+    <p:spTree>
+      <p:nvGrpSpPr>
+        <p:cNvPr id="1" name="">
+          <a:extLst>
+            <a:ext uri="{FF2B5EF4-FFF2-40B4-BE49-F238E27FC236}">
+              <a16:creationId xmlns:a16="http://schemas.microsoft.com/office/drawing/2014/main" id="{9E4871AF-6A94-2484-0C14-8305CA5AA562}"/>
+            </a:ext>
+          </a:extLst>
+        </p:cNvPr>
+        <p:cNvGrpSpPr/>
+        <p:nvPr/>
+      </p:nvGrpSpPr>
+      <p:grpSpPr>
+        <a:xfrm>
+          <a:off x="0" y="0"/>
+          <a:ext cx="0" cy="0"/>
+          <a:chOff x="0" y="0"/>
+          <a:chExt cx="0" cy="0"/>
+        </a:xfrm>
+      </p:grpSpPr>
+      <p:sp>
+        <p:nvSpPr>
+          <p:cNvPr id="3" name="Shape 1">
+            <a:extLst>
+              <a:ext uri="{FF2B5EF4-FFF2-40B4-BE49-F238E27FC236}">
+                <a16:creationId xmlns:a16="http://schemas.microsoft.com/office/drawing/2014/main" id="{30BBD088-C8A7-C790-D8F3-5A51934B20CB}"/>
+              </a:ext>
+            </a:extLst>
+          </p:cNvPr>
+          <p:cNvSpPr/>
+          <p:nvPr/>
+        </p:nvSpPr>
+        <p:spPr>
+          <a:xfrm>
+            <a:off x="365760" y="6446520"/>
+            <a:ext cx="164592" cy="164592"/>
+          </a:xfrm>
+          <a:prstGeom prst="ellipse">
+            <a:avLst/>
+          </a:prstGeom>
+          <a:solidFill>
+            <a:srgbClr val="2D4A3E"/>
+          </a:solidFill>
+          <a:ln/>
+        </p:spPr>
+        <p:txBody>
+          <a:bodyPr/>
+          <a:lstStyle/>
+          <a:p>
+            <a:endParaRPr lang="en-150"/>
+          </a:p>
+        </p:txBody>
+      </p:sp>
+      <p:sp>
+        <p:nvSpPr>
+          <p:cNvPr id="4" name="Text 2">
+            <a:extLst>
+              <a:ext uri="{FF2B5EF4-FFF2-40B4-BE49-F238E27FC236}">
+                <a16:creationId xmlns:a16="http://schemas.microsoft.com/office/drawing/2014/main" id="{787825B5-4EAF-BBF3-581E-DA81B875A107}"/>
+              </a:ext>
+            </a:extLst>
+          </p:cNvPr>
+          <p:cNvSpPr/>
+          <p:nvPr/>
+        </p:nvSpPr>
+        <p:spPr>
+          <a:xfrm>
+            <a:off x="594360" y="6382512"/>
+            <a:ext cx="1828800" cy="292608"/>
+          </a:xfrm>
+          <a:prstGeom prst="rect">
+            <a:avLst/>
+          </a:prstGeom>
+          <a:noFill/>
+          <a:ln/>
+        </p:spPr>
+        <p:txBody>
+          <a:bodyPr wrap="square" rtlCol="0" anchor="ctr"/>
+          <a:lstStyle/>
+          <a:p>
+            <a:pPr marL="0" indent="0">
+              <a:buNone/>
+            </a:pPr>
+            <a:r>
+              <a:rPr lang="en-US" sz="1200" b="1" dirty="0">
+                <a:solidFill>
+                  <a:srgbClr val="5C4A3A"/>
+                </a:solidFill>
+                <a:latin typeface="Playfair Display" pitchFamily="34" charset="0"/>
+                <a:ea typeface="Playfair Display" pitchFamily="34" charset="-122"/>
+                <a:cs typeface="Playfair Display" pitchFamily="34" charset="-120"/>
+              </a:rPr>
+              <a:t>SkillTree</a:t>
+            </a:r>
+            <a:endParaRPr lang="en-US" sz="1200" dirty="0"/>
+          </a:p>
+        </p:txBody>
+      </p:sp>
+      <p:sp>
+        <p:nvSpPr>
+          <p:cNvPr id="5" name="Text 3">
+            <a:extLst>
+              <a:ext uri="{FF2B5EF4-FFF2-40B4-BE49-F238E27FC236}">
+                <a16:creationId xmlns:a16="http://schemas.microsoft.com/office/drawing/2014/main" id="{8C252546-E9DD-AB3C-7814-7D3354E70DF6}"/>
+              </a:ext>
+            </a:extLst>
+          </p:cNvPr>
+          <p:cNvSpPr/>
+          <p:nvPr/>
+        </p:nvSpPr>
+        <p:spPr>
+          <a:xfrm>
+            <a:off x="11155680" y="6382512"/>
+            <a:ext cx="822960" cy="292608"/>
+          </a:xfrm>
+          <a:prstGeom prst="rect">
+            <a:avLst/>
+          </a:prstGeom>
+          <a:noFill/>
+          <a:ln/>
+        </p:spPr>
+        <p:txBody>
+          <a:bodyPr wrap="square" rtlCol="0" anchor="ctr"/>
+          <a:lstStyle/>
+          <a:p>
+            <a:pPr marL="0" indent="0" algn="r">
+              <a:buNone/>
+            </a:pPr>
+            <a:r>
+              <a:rPr lang="en-US" sz="1000" dirty="0">
+                <a:solidFill>
+                  <a:srgbClr val="9B9585"/>
+                </a:solidFill>
+                <a:latin typeface="DM Sans" pitchFamily="34" charset="0"/>
+                <a:ea typeface="DM Sans" pitchFamily="34" charset="-122"/>
+                <a:cs typeface="DM Sans" pitchFamily="34" charset="-120"/>
+              </a:rPr>
+              <a:t>8 / 11</a:t>
+            </a:r>
+            <a:endParaRPr lang="en-US" sz="1000" dirty="0"/>
+          </a:p>
+        </p:txBody>
+      </p:sp>
+      <p:sp>
+        <p:nvSpPr>
+          <p:cNvPr id="8" name="Text 6">
+            <a:extLst>
+              <a:ext uri="{FF2B5EF4-FFF2-40B4-BE49-F238E27FC236}">
+                <a16:creationId xmlns:a16="http://schemas.microsoft.com/office/drawing/2014/main" id="{0C834DB9-B7BE-0F31-6E79-24AAD8BDB867}"/>
+              </a:ext>
+            </a:extLst>
+          </p:cNvPr>
+          <p:cNvSpPr/>
+          <p:nvPr/>
+        </p:nvSpPr>
+        <p:spPr>
+          <a:xfrm>
+            <a:off x="822960" y="2011680"/>
+            <a:ext cx="10515600" cy="4114800"/>
+          </a:xfrm>
+          <a:prstGeom prst="rect">
+            <a:avLst/>
+          </a:prstGeom>
+          <a:noFill/>
+          <a:ln/>
+        </p:spPr>
+        <p:txBody>
+          <a:bodyPr wrap="square" rtlCol="0" anchor="ctr"/>
+          <a:lstStyle/>
+          <a:p>
+            <a:pPr marL="228600" indent="-228600">
+              <a:lnSpc>
+                <a:spcPct val="130000"/>
+              </a:lnSpc>
+              <a:spcAft>
+                <a:spcPts val="1400"/>
+              </a:spcAft>
+              <a:buSzPct val="100000"/>
+              <a:buChar char="•"/>
+            </a:pPr>
+            <a:endParaRPr lang="en-US" sz="1800" dirty="0"/>
+          </a:p>
+        </p:txBody>
+      </p:sp>
+      <p:pic>
+        <p:nvPicPr>
+          <p:cNvPr id="10" name="Picture 9">
+            <a:extLst>
+              <a:ext uri="{FF2B5EF4-FFF2-40B4-BE49-F238E27FC236}">
+                <a16:creationId xmlns:a16="http://schemas.microsoft.com/office/drawing/2014/main" id="{3E45DE17-773C-D8E3-35FF-91A251AB8EBD}"/>
+              </a:ext>
+            </a:extLst>
+          </p:cNvPr>
+          <p:cNvPicPr>
+            <a:picLocks noChangeAspect="1"/>
+          </p:cNvPicPr>
+          <p:nvPr/>
+        </p:nvPicPr>
+        <p:blipFill>
+          <a:blip r:embed="rId3"/>
+          <a:stretch>
+            <a:fillRect/>
+          </a:stretch>
+        </p:blipFill>
+        <p:spPr>
+          <a:xfrm>
+            <a:off x="0" y="0"/>
+            <a:ext cx="12049932" cy="6858000"/>
+          </a:xfrm>
+          <a:prstGeom prst="rect">
+            <a:avLst/>
+          </a:prstGeom>
+        </p:spPr>
+      </p:pic>
+    </p:spTree>
+    <p:extLst>
+      <p:ext uri="{BB962C8B-B14F-4D97-AF65-F5344CB8AC3E}">
+        <p14:creationId xmlns:p14="http://schemas.microsoft.com/office/powerpoint/2010/main" val="3054574029"/>
+      </p:ext>
+    </p:extLst>
+  </p:cSld>
+  <p:clrMapOvr>
+    <a:masterClrMapping/>
+  </p:clrMapOvr>
+</p:sld>
+</file>
+
+<file path=ppt/slides/slide11.xml><?xml version="1.0" encoding="utf-8"?>
+<p:sld xmlns:a="http://schemas.openxmlformats.org/drawingml/2006/main" xmlns:r="http://schemas.openxmlformats.org/officeDocument/2006/relationships" xmlns:p="http://schemas.openxmlformats.org/presentationml/2006/main">
+  <p:cSld>
+    <p:spTree>
+      <p:nvGrpSpPr>
+        <p:cNvPr id="1" name=""/>
+        <p:cNvGrpSpPr/>
+        <p:nvPr/>
+      </p:nvGrpSpPr>
+      <p:grpSpPr>
+        <a:xfrm>
+          <a:off x="0" y="0"/>
+          <a:ext cx="0" cy="0"/>
+          <a:chOff x="0" y="0"/>
+          <a:chExt cx="0" cy="0"/>
+        </a:xfrm>
+      </p:grpSpPr>
+      <p:pic>
+        <p:nvPicPr>
+          <p:cNvPr id="5" name="Picture 4">
+            <a:extLst>
+              <a:ext uri="{FF2B5EF4-FFF2-40B4-BE49-F238E27FC236}">
+                <a16:creationId xmlns:a16="http://schemas.microsoft.com/office/drawing/2014/main" id="{63E02CE0-69DE-A8B5-3D8B-9E81515EC390}"/>
+              </a:ext>
+            </a:extLst>
+          </p:cNvPr>
+          <p:cNvPicPr>
+            <a:picLocks noChangeAspect="1"/>
+          </p:cNvPicPr>
+          <p:nvPr/>
+        </p:nvPicPr>
+        <p:blipFill>
+          <a:blip r:embed="rId2"/>
+          <a:stretch>
+            <a:fillRect/>
+          </a:stretch>
+        </p:blipFill>
+        <p:spPr>
+          <a:xfrm>
+            <a:off x="0" y="-44645"/>
+            <a:ext cx="12192000" cy="6947287"/>
+          </a:xfrm>
+          <a:prstGeom prst="rect">
+            <a:avLst/>
+          </a:prstGeom>
+        </p:spPr>
+      </p:pic>
+    </p:spTree>
+    <p:extLst>
+      <p:ext uri="{BB962C8B-B14F-4D97-AF65-F5344CB8AC3E}">
+        <p14:creationId xmlns:p14="http://schemas.microsoft.com/office/powerpoint/2010/main" val="4002165055"/>
+      </p:ext>
+    </p:extLst>
+  </p:cSld>
+  <p:clrMapOvr>
+    <a:masterClrMapping/>
+  </p:clrMapOvr>
+</p:sld>
+</file>
+
+<file path=ppt/slides/slide12.xml><?xml version="1.0" encoding="utf-8"?>
+<p:sld xmlns:a="http://schemas.openxmlformats.org/drawingml/2006/main" xmlns:r="http://schemas.openxmlformats.org/officeDocument/2006/relationships" xmlns:p="http://schemas.openxmlformats.org/presentationml/2006/main">
+  <p:cSld name="Slide 10">
+    <p:bg>
+      <p:bgPr>
+        <a:solidFill>
+          <a:srgbClr val="FAF6F0"/>
+        </a:solidFill>
+        <a:effectLst/>
+      </p:bgPr>
+    </p:bg>
+    <p:spTree>
+      <p:nvGrpSpPr>
+        <p:cNvPr id="1" name=""/>
+        <p:cNvGrpSpPr/>
+        <p:nvPr/>
+      </p:nvGrpSpPr>
+      <p:grpSpPr>
+        <a:xfrm>
+          <a:off x="0" y="0"/>
+          <a:ext cx="0" cy="0"/>
+          <a:chOff x="0" y="0"/>
+          <a:chExt cx="0" cy="0"/>
+        </a:xfrm>
+      </p:grpSpPr>
+      <p:sp>
+        <p:nvSpPr>
+          <p:cNvPr id="2" name="Shape 0"/>
+          <p:cNvSpPr/>
+          <p:nvPr/>
+        </p:nvSpPr>
+        <p:spPr>
+          <a:xfrm>
+            <a:off x="0" y="0"/>
+            <a:ext cx="12188952" cy="73152"/>
+          </a:xfrm>
+          <a:prstGeom prst="rect">
+            <a:avLst/>
+          </a:prstGeom>
+          <a:solidFill>
+            <a:srgbClr val="2D4A3E"/>
+          </a:solidFill>
+          <a:ln/>
+        </p:spPr>
+        <p:txBody>
+          <a:bodyPr/>
+          <a:lstStyle/>
+          <a:p>
+            <a:endParaRPr lang="en-150"/>
+          </a:p>
+        </p:txBody>
+      </p:sp>
+      <p:sp>
+        <p:nvSpPr>
+          <p:cNvPr id="3" name="Shape 1"/>
+          <p:cNvSpPr/>
+          <p:nvPr/>
+        </p:nvSpPr>
+        <p:spPr>
+          <a:xfrm>
+            <a:off x="365760" y="6446520"/>
+            <a:ext cx="164592" cy="164592"/>
+          </a:xfrm>
+          <a:prstGeom prst="ellipse">
+            <a:avLst/>
+          </a:prstGeom>
+          <a:solidFill>
+            <a:srgbClr val="2D4A3E"/>
+          </a:solidFill>
+          <a:ln/>
+        </p:spPr>
+        <p:txBody>
+          <a:bodyPr/>
+          <a:lstStyle/>
+          <a:p>
+            <a:endParaRPr lang="en-150"/>
+          </a:p>
+        </p:txBody>
+      </p:sp>
+      <p:sp>
+        <p:nvSpPr>
+          <p:cNvPr id="4" name="Text 2"/>
+          <p:cNvSpPr/>
+          <p:nvPr/>
+        </p:nvSpPr>
+        <p:spPr>
+          <a:xfrm>
+            <a:off x="594360" y="6382512"/>
+            <a:ext cx="1828800" cy="292608"/>
+          </a:xfrm>
+          <a:prstGeom prst="rect">
+            <a:avLst/>
+          </a:prstGeom>
+          <a:noFill/>
+          <a:ln/>
+        </p:spPr>
+        <p:txBody>
+          <a:bodyPr wrap="square" rtlCol="0" anchor="ctr"/>
+          <a:lstStyle/>
+          <a:p>
+            <a:pPr marL="0" indent="0">
+              <a:buNone/>
+            </a:pPr>
+            <a:r>
+              <a:rPr lang="en-US" sz="1200" b="1" dirty="0">
+                <a:solidFill>
+                  <a:srgbClr val="5C4A3A"/>
+                </a:solidFill>
+                <a:latin typeface="Playfair Display" pitchFamily="34" charset="0"/>
+                <a:ea typeface="Playfair Display" pitchFamily="34" charset="-122"/>
+                <a:cs typeface="Playfair Display" pitchFamily="34" charset="-120"/>
+              </a:rPr>
+              <a:t>SkillTree</a:t>
+            </a:r>
+            <a:endParaRPr lang="en-US" sz="1200" dirty="0"/>
+          </a:p>
+        </p:txBody>
+      </p:sp>
+      <p:sp>
+        <p:nvSpPr>
+          <p:cNvPr id="5" name="Text 3"/>
+          <p:cNvSpPr/>
+          <p:nvPr/>
+        </p:nvSpPr>
+        <p:spPr>
+          <a:xfrm>
+            <a:off x="11155680" y="6382512"/>
+            <a:ext cx="822960" cy="292608"/>
+          </a:xfrm>
+          <a:prstGeom prst="rect">
+            <a:avLst/>
+          </a:prstGeom>
+          <a:noFill/>
+          <a:ln/>
+        </p:spPr>
+        <p:txBody>
+          <a:bodyPr wrap="square" rtlCol="0" anchor="ctr"/>
+          <a:lstStyle/>
+          <a:p>
+            <a:pPr marL="0" indent="0" algn="r">
+              <a:buNone/>
+            </a:pPr>
+            <a:r>
+              <a:rPr lang="en-US" sz="1000" dirty="0">
+                <a:solidFill>
+                  <a:srgbClr val="9B9585"/>
+                </a:solidFill>
+                <a:latin typeface="DM Sans" pitchFamily="34" charset="0"/>
+                <a:ea typeface="DM Sans" pitchFamily="34" charset="-122"/>
+                <a:cs typeface="DM Sans" pitchFamily="34" charset="-120"/>
+              </a:rPr>
+              <a:t>9 / 11</a:t>
+            </a:r>
+            <a:endParaRPr lang="en-US" sz="1000" dirty="0"/>
+          </a:p>
+        </p:txBody>
+      </p:sp>
+      <p:sp>
+        <p:nvSpPr>
+          <p:cNvPr id="6" name="Text 4"/>
+          <p:cNvSpPr/>
+          <p:nvPr/>
+        </p:nvSpPr>
+        <p:spPr>
+          <a:xfrm>
+            <a:off x="640080" y="411480"/>
+            <a:ext cx="10972800" cy="274320"/>
+          </a:xfrm>
+          <a:prstGeom prst="rect">
+            <a:avLst/>
+          </a:prstGeom>
+          <a:noFill/>
+          <a:ln/>
+        </p:spPr>
+        <p:txBody>
+          <a:bodyPr wrap="square" rtlCol="0" anchor="ctr"/>
+          <a:lstStyle/>
+          <a:p>
+            <a:pPr marL="0" indent="0">
+              <a:buNone/>
+            </a:pPr>
+            <a:r>
+              <a:rPr lang="en-US" sz="1100" b="1" kern="0" spc="150" dirty="0">
+                <a:solidFill>
+                  <a:srgbClr val="2D4A3E"/>
+                </a:solidFill>
+                <a:latin typeface="DM Sans" pitchFamily="34" charset="0"/>
+                <a:ea typeface="DM Sans" pitchFamily="34" charset="-122"/>
+                <a:cs typeface="DM Sans" pitchFamily="34" charset="-120"/>
+              </a:rPr>
+              <a:t>09</a:t>
+            </a:r>
+            <a:endParaRPr lang="en-US" sz="1100" dirty="0"/>
+          </a:p>
+        </p:txBody>
+      </p:sp>
+      <p:sp>
+        <p:nvSpPr>
+          <p:cNvPr id="7" name="Text 5"/>
+          <p:cNvSpPr/>
+          <p:nvPr/>
+        </p:nvSpPr>
+        <p:spPr>
+          <a:xfrm>
+            <a:off x="640080" y="640080"/>
+            <a:ext cx="10972800" cy="914400"/>
+          </a:xfrm>
+          <a:prstGeom prst="rect">
+            <a:avLst/>
+          </a:prstGeom>
+          <a:noFill/>
+          <a:ln/>
+        </p:spPr>
+        <p:txBody>
+          <a:bodyPr wrap="square" rtlCol="0" anchor="ctr"/>
+          <a:lstStyle/>
+          <a:p>
+            <a:pPr marL="0" indent="0">
+              <a:buNone/>
+            </a:pPr>
+            <a:r>
+              <a:rPr lang="en-US" sz="4000" kern="0" spc="-100" dirty="0">
+                <a:solidFill>
+                  <a:srgbClr val="1A1A18"/>
+                </a:solidFill>
+                <a:latin typeface="Playfair Display" pitchFamily="34" charset="0"/>
+                <a:ea typeface="Playfair Display" pitchFamily="34" charset="-122"/>
+                <a:cs typeface="Playfair Display" pitchFamily="34" charset="-120"/>
+              </a:rPr>
+              <a:t>Reflektsioon: mis tuli kergelt</a:t>
+            </a:r>
+            <a:endParaRPr lang="en-US" sz="4000" dirty="0"/>
+          </a:p>
+        </p:txBody>
+      </p:sp>
+      <p:sp>
+        <p:nvSpPr>
+          <p:cNvPr id="8" name="Text 6"/>
+          <p:cNvSpPr/>
+          <p:nvPr/>
+        </p:nvSpPr>
+        <p:spPr>
+          <a:xfrm>
+            <a:off x="822960" y="2011680"/>
+            <a:ext cx="10515600" cy="4114800"/>
+          </a:xfrm>
+          <a:prstGeom prst="rect">
+            <a:avLst/>
+          </a:prstGeom>
+          <a:noFill/>
+          <a:ln/>
+        </p:spPr>
+        <p:txBody>
+          <a:bodyPr wrap="square" rtlCol="0" anchor="ctr"/>
+          <a:lstStyle/>
+          <a:p>
+            <a:pPr marL="228600" indent="-228600">
+              <a:lnSpc>
+                <a:spcPct val="130000"/>
+              </a:lnSpc>
+              <a:spcAft>
+                <a:spcPts val="1400"/>
+              </a:spcAft>
+              <a:buSzPct val="100000"/>
+              <a:buChar char="•"/>
+            </a:pPr>
+            <a:r>
+              <a:rPr lang="en-US" sz="1800" dirty="0">
+                <a:solidFill>
+                  <a:srgbClr val="5C4A3A"/>
+                </a:solidFill>
+                <a:latin typeface="DM Sans" pitchFamily="34" charset="0"/>
+                <a:ea typeface="DM Sans" pitchFamily="34" charset="-122"/>
+                <a:cs typeface="DM Sans" pitchFamily="34" charset="-120"/>
+              </a:rPr>
+              <a:t>Värvipalett ja </a:t>
+            </a:r>
+            <a:r>
+              <a:rPr lang="en-US" sz="1800" dirty="0" err="1">
+                <a:solidFill>
+                  <a:srgbClr val="5C4A3A"/>
+                </a:solidFill>
+                <a:latin typeface="DM Sans" pitchFamily="34" charset="0"/>
+                <a:ea typeface="DM Sans" pitchFamily="34" charset="-122"/>
+                <a:cs typeface="DM Sans" pitchFamily="34" charset="-120"/>
+              </a:rPr>
+              <a:t>fontide</a:t>
+            </a:r>
+            <a:r>
+              <a:rPr lang="en-US" sz="1800" dirty="0">
+                <a:solidFill>
+                  <a:srgbClr val="5C4A3A"/>
+                </a:solidFill>
+                <a:latin typeface="DM Sans" pitchFamily="34" charset="0"/>
+                <a:ea typeface="DM Sans" pitchFamily="34" charset="-122"/>
+                <a:cs typeface="DM Sans" pitchFamily="34" charset="-120"/>
+              </a:rPr>
+              <a:t> valik — tahtsin </a:t>
+            </a:r>
+            <a:r>
+              <a:rPr lang="en-US" sz="1800" dirty="0" err="1">
+                <a:solidFill>
+                  <a:srgbClr val="5C4A3A"/>
+                </a:solidFill>
+                <a:latin typeface="DM Sans" pitchFamily="34" charset="0"/>
+                <a:ea typeface="DM Sans" pitchFamily="34" charset="-122"/>
+                <a:cs typeface="DM Sans" pitchFamily="34" charset="-120"/>
+              </a:rPr>
+              <a:t>sooja</a:t>
+            </a:r>
+            <a:r>
+              <a:rPr lang="en-US" sz="1800" dirty="0">
+                <a:solidFill>
+                  <a:srgbClr val="5C4A3A"/>
+                </a:solidFill>
+                <a:latin typeface="DM Sans" pitchFamily="34" charset="0"/>
+                <a:ea typeface="DM Sans" pitchFamily="34" charset="-122"/>
+                <a:cs typeface="DM Sans" pitchFamily="34" charset="-120"/>
+              </a:rPr>
+              <a:t>, päeviku tunnet</a:t>
+            </a:r>
+            <a:endParaRPr lang="en-US" sz="1800" dirty="0"/>
+          </a:p>
+          <a:p>
+            <a:pPr marL="228600" indent="-228600">
+              <a:lnSpc>
+                <a:spcPct val="130000"/>
+              </a:lnSpc>
+              <a:spcAft>
+                <a:spcPts val="1400"/>
+              </a:spcAft>
+              <a:buSzPct val="100000"/>
+              <a:buChar char="•"/>
+            </a:pPr>
+            <a:r>
+              <a:rPr lang="en-US" sz="1800" dirty="0">
+                <a:solidFill>
+                  <a:srgbClr val="5C4A3A"/>
+                </a:solidFill>
+                <a:latin typeface="DM Sans" pitchFamily="34" charset="0"/>
+                <a:ea typeface="DM Sans" pitchFamily="34" charset="-122"/>
+                <a:cs typeface="DM Sans" pitchFamily="34" charset="-120"/>
+              </a:rPr>
+              <a:t>Andmestruktuur — oskuste </a:t>
+            </a:r>
+            <a:r>
+              <a:rPr lang="en-US" sz="1800" dirty="0" err="1">
+                <a:solidFill>
+                  <a:srgbClr val="5C4A3A"/>
+                </a:solidFill>
+                <a:latin typeface="DM Sans" pitchFamily="34" charset="0"/>
+                <a:ea typeface="DM Sans" pitchFamily="34" charset="-122"/>
+                <a:cs typeface="DM Sans" pitchFamily="34" charset="-120"/>
+              </a:rPr>
+              <a:t>sõltuvuste</a:t>
+            </a:r>
+            <a:r>
+              <a:rPr lang="en-US" sz="1800" dirty="0">
+                <a:solidFill>
+                  <a:srgbClr val="5C4A3A"/>
+                </a:solidFill>
+                <a:latin typeface="DM Sans" pitchFamily="34" charset="0"/>
+                <a:ea typeface="DM Sans" pitchFamily="34" charset="-122"/>
+                <a:cs typeface="DM Sans" pitchFamily="34" charset="-120"/>
+              </a:rPr>
+              <a:t> </a:t>
+            </a:r>
+            <a:r>
+              <a:rPr lang="en-US" sz="1800" dirty="0" err="1">
+                <a:solidFill>
+                  <a:srgbClr val="5C4A3A"/>
+                </a:solidFill>
+                <a:latin typeface="DM Sans" pitchFamily="34" charset="0"/>
+                <a:ea typeface="DM Sans" pitchFamily="34" charset="-122"/>
+                <a:cs typeface="DM Sans" pitchFamily="34" charset="-120"/>
+              </a:rPr>
+              <a:t>graafikuks</a:t>
+            </a:r>
+            <a:r>
+              <a:rPr lang="en-US" sz="1800" dirty="0">
+                <a:solidFill>
+                  <a:srgbClr val="5C4A3A"/>
+                </a:solidFill>
+                <a:latin typeface="DM Sans" pitchFamily="34" charset="0"/>
+                <a:ea typeface="DM Sans" pitchFamily="34" charset="-122"/>
+                <a:cs typeface="DM Sans" pitchFamily="34" charset="-120"/>
+              </a:rPr>
+              <a:t> </a:t>
+            </a:r>
+            <a:r>
+              <a:rPr lang="en-US" sz="1800" dirty="0" err="1">
+                <a:solidFill>
+                  <a:srgbClr val="5C4A3A"/>
+                </a:solidFill>
+                <a:latin typeface="DM Sans" pitchFamily="34" charset="0"/>
+                <a:ea typeface="DM Sans" pitchFamily="34" charset="-122"/>
+                <a:cs typeface="DM Sans" pitchFamily="34" charset="-120"/>
+              </a:rPr>
+              <a:t>tegemine</a:t>
+            </a:r>
+            <a:r>
+              <a:rPr lang="en-US" sz="1800" dirty="0">
+                <a:solidFill>
+                  <a:srgbClr val="5C4A3A"/>
+                </a:solidFill>
+                <a:latin typeface="DM Sans" pitchFamily="34" charset="0"/>
+                <a:ea typeface="DM Sans" pitchFamily="34" charset="-122"/>
+                <a:cs typeface="DM Sans" pitchFamily="34" charset="-120"/>
+              </a:rPr>
+              <a:t> </a:t>
+            </a:r>
+            <a:r>
+              <a:rPr lang="en-US" sz="1800" dirty="0" err="1">
+                <a:solidFill>
+                  <a:srgbClr val="5C4A3A"/>
+                </a:solidFill>
+                <a:latin typeface="DM Sans" pitchFamily="34" charset="0"/>
+                <a:ea typeface="DM Sans" pitchFamily="34" charset="-122"/>
+                <a:cs typeface="DM Sans" pitchFamily="34" charset="-120"/>
+              </a:rPr>
+              <a:t>tuli</a:t>
+            </a:r>
+            <a:r>
+              <a:rPr lang="en-US" sz="1800" dirty="0">
+                <a:solidFill>
+                  <a:srgbClr val="5C4A3A"/>
+                </a:solidFill>
+                <a:latin typeface="DM Sans" pitchFamily="34" charset="0"/>
+                <a:ea typeface="DM Sans" pitchFamily="34" charset="-122"/>
+                <a:cs typeface="DM Sans" pitchFamily="34" charset="-120"/>
+              </a:rPr>
+              <a:t> </a:t>
+            </a:r>
+            <a:r>
+              <a:rPr lang="en-US" sz="1800" dirty="0" err="1">
+                <a:solidFill>
+                  <a:srgbClr val="5C4A3A"/>
+                </a:solidFill>
+                <a:latin typeface="DM Sans" pitchFamily="34" charset="0"/>
+                <a:ea typeface="DM Sans" pitchFamily="34" charset="-122"/>
+                <a:cs typeface="DM Sans" pitchFamily="34" charset="-120"/>
+              </a:rPr>
+              <a:t>lihtsasti</a:t>
+            </a:r>
+            <a:endParaRPr lang="en-US" sz="1800" dirty="0"/>
+          </a:p>
+        </p:txBody>
+      </p:sp>
+    </p:spTree>
+  </p:cSld>
+  <p:clrMapOvr>
+    <a:masterClrMapping/>
+  </p:clrMapOvr>
+</p:sld>
+</file>
+
+<file path=ppt/slides/slide13.xml><?xml version="1.0" encoding="utf-8"?>
+<p:sld xmlns:a="http://schemas.openxmlformats.org/drawingml/2006/main" xmlns:r="http://schemas.openxmlformats.org/officeDocument/2006/relationships" xmlns:p="http://schemas.openxmlformats.org/presentationml/2006/main">
   <p:cSld name="Slide 11">
     <p:bg>
       <p:bgPr>
@@ -2991,7 +3964,7 @@
                 <a:ea typeface="DM Sans" pitchFamily="34" charset="-122"/>
                 <a:cs typeface="DM Sans" pitchFamily="34" charset="-120"/>
               </a:rPr>
-              <a:t>enda</a:t>
+              <a:t>ennast</a:t>
             </a:r>
             <a:r>
               <a:rPr lang="en-US" sz="2200" dirty="0">
@@ -3013,7 +3986,7 @@
                 <a:ea typeface="DM Sans" pitchFamily="34" charset="-122"/>
                 <a:cs typeface="DM Sans" pitchFamily="34" charset="-120"/>
               </a:rPr>
-              <a:t>arendamine</a:t>
+              <a:t>võib</a:t>
             </a:r>
             <a:r>
               <a:rPr lang="en-US" sz="2200" dirty="0">
@@ -3035,7 +4008,7 @@
                 <a:ea typeface="DM Sans" pitchFamily="34" charset="-122"/>
                 <a:cs typeface="DM Sans" pitchFamily="34" charset="-120"/>
               </a:rPr>
-              <a:t>ei</a:t>
+              <a:t>arendada</a:t>
             </a:r>
             <a:r>
               <a:rPr lang="en-US" sz="2200" dirty="0">
@@ -3057,7 +4030,7 @@
                 <a:ea typeface="DM Sans" pitchFamily="34" charset="-122"/>
                 <a:cs typeface="DM Sans" pitchFamily="34" charset="-120"/>
               </a:rPr>
-              <a:t>küsi</a:t>
+              <a:t>igas</a:t>
             </a:r>
             <a:r>
               <a:rPr lang="en-US" sz="2200" dirty="0">
@@ -3079,7 +4052,7 @@
                 <a:ea typeface="DM Sans" pitchFamily="34" charset="-122"/>
                 <a:cs typeface="DM Sans" pitchFamily="34" charset="-120"/>
               </a:rPr>
-              <a:t>vanust</a:t>
+              <a:t>vanuses</a:t>
             </a:r>
             <a:endParaRPr lang="en-US" sz="2200" dirty="0"/>
           </a:p>
@@ -6441,7 +7414,7 @@
 
 <file path=ppt/slides/slide9.xml><?xml version="1.0" encoding="utf-8"?>
 <p:sld xmlns:a="http://schemas.openxmlformats.org/drawingml/2006/main" xmlns:r="http://schemas.openxmlformats.org/officeDocument/2006/relationships" xmlns:p="http://schemas.openxmlformats.org/presentationml/2006/main">
-  <p:cSld name="Slide 10">
+  <p:cSld>
     <p:bg>
       <p:bgPr>
         <a:solidFill>
@@ -6452,7 +7425,13 @@
     </p:bg>
     <p:spTree>
       <p:nvGrpSpPr>
-        <p:cNvPr id="1" name=""/>
+        <p:cNvPr id="1" name="">
+          <a:extLst>
+            <a:ext uri="{FF2B5EF4-FFF2-40B4-BE49-F238E27FC236}">
+              <a16:creationId xmlns:a16="http://schemas.microsoft.com/office/drawing/2014/main" id="{ECE105D4-CCAD-CB2B-CB65-AD7BC5153BCF}"/>
+            </a:ext>
+          </a:extLst>
+        </p:cNvPr>
         <p:cNvGrpSpPr/>
         <p:nvPr/>
       </p:nvGrpSpPr>
@@ -6466,61 +7445,13 @@
       </p:grpSpPr>
       <p:sp>
         <p:nvSpPr>
-          <p:cNvPr id="2" name="Shape 0"/>
-          <p:cNvSpPr/>
-          <p:nvPr/>
-        </p:nvSpPr>
-        <p:spPr>
-          <a:xfrm>
-            <a:off x="0" y="0"/>
-            <a:ext cx="12188952" cy="73152"/>
-          </a:xfrm>
-          <a:prstGeom prst="rect">
-            <a:avLst/>
-          </a:prstGeom>
-          <a:solidFill>
-            <a:srgbClr val="2D4A3E"/>
-          </a:solidFill>
-          <a:ln/>
-        </p:spPr>
-        <p:txBody>
-          <a:bodyPr/>
-          <a:lstStyle/>
-          <a:p>
-            <a:endParaRPr lang="en-150"/>
-          </a:p>
-        </p:txBody>
-      </p:sp>
-      <p:sp>
-        <p:nvSpPr>
-          <p:cNvPr id="3" name="Shape 1"/>
-          <p:cNvSpPr/>
-          <p:nvPr/>
-        </p:nvSpPr>
-        <p:spPr>
-          <a:xfrm>
-            <a:off x="365760" y="6446520"/>
-            <a:ext cx="164592" cy="164592"/>
-          </a:xfrm>
-          <a:prstGeom prst="ellipse">
-            <a:avLst/>
-          </a:prstGeom>
-          <a:solidFill>
-            <a:srgbClr val="2D4A3E"/>
-          </a:solidFill>
-          <a:ln/>
-        </p:spPr>
-        <p:txBody>
-          <a:bodyPr/>
-          <a:lstStyle/>
-          <a:p>
-            <a:endParaRPr lang="en-150"/>
-          </a:p>
-        </p:txBody>
-      </p:sp>
-      <p:sp>
-        <p:nvSpPr>
-          <p:cNvPr id="4" name="Text 2"/>
+          <p:cNvPr id="4" name="Text 2">
+            <a:extLst>
+              <a:ext uri="{FF2B5EF4-FFF2-40B4-BE49-F238E27FC236}">
+                <a16:creationId xmlns:a16="http://schemas.microsoft.com/office/drawing/2014/main" id="{93EFCFB5-528D-CC09-29DB-D770EC5AC685}"/>
+              </a:ext>
+            </a:extLst>
+          </p:cNvPr>
           <p:cNvSpPr/>
           <p:nvPr/>
         </p:nvSpPr>
@@ -6542,24 +7473,19 @@
             <a:pPr marL="0" indent="0">
               <a:buNone/>
             </a:pPr>
-            <a:r>
-              <a:rPr lang="en-US" sz="1200" b="1" dirty="0">
-                <a:solidFill>
-                  <a:srgbClr val="5C4A3A"/>
-                </a:solidFill>
-                <a:latin typeface="Playfair Display" pitchFamily="34" charset="0"/>
-                <a:ea typeface="Playfair Display" pitchFamily="34" charset="-122"/>
-                <a:cs typeface="Playfair Display" pitchFamily="34" charset="-120"/>
-              </a:rPr>
-              <a:t>SkillTree</a:t>
-            </a:r>
             <a:endParaRPr lang="en-US" sz="1200" dirty="0"/>
           </a:p>
         </p:txBody>
       </p:sp>
       <p:sp>
         <p:nvSpPr>
-          <p:cNvPr id="5" name="Text 3"/>
+          <p:cNvPr id="5" name="Text 3">
+            <a:extLst>
+              <a:ext uri="{FF2B5EF4-FFF2-40B4-BE49-F238E27FC236}">
+                <a16:creationId xmlns:a16="http://schemas.microsoft.com/office/drawing/2014/main" id="{0946AE91-CB08-6D46-52CB-B6FF69D11394}"/>
+              </a:ext>
+            </a:extLst>
+          </p:cNvPr>
           <p:cNvSpPr/>
           <p:nvPr/>
         </p:nvSpPr>
@@ -6581,24 +7507,19 @@
             <a:pPr marL="0" indent="0" algn="r">
               <a:buNone/>
             </a:pPr>
-            <a:r>
-              <a:rPr lang="en-US" sz="1000" dirty="0">
-                <a:solidFill>
-                  <a:srgbClr val="9B9585"/>
-                </a:solidFill>
-                <a:latin typeface="DM Sans" pitchFamily="34" charset="0"/>
-                <a:ea typeface="DM Sans" pitchFamily="34" charset="-122"/>
-                <a:cs typeface="DM Sans" pitchFamily="34" charset="-120"/>
-              </a:rPr>
-              <a:t>9 / 11</a:t>
-            </a:r>
             <a:endParaRPr lang="en-US" sz="1000" dirty="0"/>
           </a:p>
         </p:txBody>
       </p:sp>
       <p:sp>
         <p:nvSpPr>
-          <p:cNvPr id="6" name="Text 4"/>
+          <p:cNvPr id="6" name="Text 4">
+            <a:extLst>
+              <a:ext uri="{FF2B5EF4-FFF2-40B4-BE49-F238E27FC236}">
+                <a16:creationId xmlns:a16="http://schemas.microsoft.com/office/drawing/2014/main" id="{10D558F8-A5C4-D332-28A0-48A57E4B5FE4}"/>
+              </a:ext>
+            </a:extLst>
+          </p:cNvPr>
           <p:cNvSpPr/>
           <p:nvPr/>
         </p:nvSpPr>
@@ -6620,24 +7541,19 @@
             <a:pPr marL="0" indent="0">
               <a:buNone/>
             </a:pPr>
-            <a:r>
-              <a:rPr lang="en-US" sz="1100" b="1" kern="0" spc="150" dirty="0">
-                <a:solidFill>
-                  <a:srgbClr val="2D4A3E"/>
-                </a:solidFill>
-                <a:latin typeface="DM Sans" pitchFamily="34" charset="0"/>
-                <a:ea typeface="DM Sans" pitchFamily="34" charset="-122"/>
-                <a:cs typeface="DM Sans" pitchFamily="34" charset="-120"/>
-              </a:rPr>
-              <a:t>09</a:t>
-            </a:r>
             <a:endParaRPr lang="en-US" sz="1100" dirty="0"/>
           </a:p>
         </p:txBody>
       </p:sp>
       <p:sp>
         <p:nvSpPr>
-          <p:cNvPr id="7" name="Text 5"/>
+          <p:cNvPr id="7" name="Text 5">
+            <a:extLst>
+              <a:ext uri="{FF2B5EF4-FFF2-40B4-BE49-F238E27FC236}">
+                <a16:creationId xmlns:a16="http://schemas.microsoft.com/office/drawing/2014/main" id="{43EDFC30-16DE-0780-862E-8A5FA14DE271}"/>
+              </a:ext>
+            </a:extLst>
+          </p:cNvPr>
           <p:cNvSpPr/>
           <p:nvPr/>
         </p:nvSpPr>
@@ -6659,24 +7575,19 @@
             <a:pPr marL="0" indent="0">
               <a:buNone/>
             </a:pPr>
-            <a:r>
-              <a:rPr lang="en-US" sz="4000" kern="0" spc="-100" dirty="0">
-                <a:solidFill>
-                  <a:srgbClr val="1A1A18"/>
-                </a:solidFill>
-                <a:latin typeface="Playfair Display" pitchFamily="34" charset="0"/>
-                <a:ea typeface="Playfair Display" pitchFamily="34" charset="-122"/>
-                <a:cs typeface="Playfair Display" pitchFamily="34" charset="-120"/>
-              </a:rPr>
-              <a:t>Reflektsioon: mis tuli kergelt</a:t>
-            </a:r>
             <a:endParaRPr lang="en-US" sz="4000" dirty="0"/>
           </a:p>
         </p:txBody>
       </p:sp>
       <p:sp>
         <p:nvSpPr>
-          <p:cNvPr id="8" name="Text 6"/>
+          <p:cNvPr id="8" name="Text 6">
+            <a:extLst>
+              <a:ext uri="{FF2B5EF4-FFF2-40B4-BE49-F238E27FC236}">
+                <a16:creationId xmlns:a16="http://schemas.microsoft.com/office/drawing/2014/main" id="{F58B027B-F32C-0B88-5952-96C7640177A2}"/>
+              </a:ext>
+            </a:extLst>
+          </p:cNvPr>
           <p:cNvSpPr/>
           <p:nvPr/>
         </p:nvSpPr>
@@ -6705,140 +7616,46 @@
               <a:buSzPct val="100000"/>
               <a:buChar char="•"/>
             </a:pPr>
-            <a:r>
-              <a:rPr lang="en-US" sz="1800" dirty="0">
-                <a:solidFill>
-                  <a:srgbClr val="5C4A3A"/>
-                </a:solidFill>
-                <a:latin typeface="DM Sans" pitchFamily="34" charset="0"/>
-                <a:ea typeface="DM Sans" pitchFamily="34" charset="-122"/>
-                <a:cs typeface="DM Sans" pitchFamily="34" charset="-120"/>
-              </a:rPr>
-              <a:t>Värvipalett ja </a:t>
-            </a:r>
-            <a:r>
-              <a:rPr lang="en-US" sz="1800">
-                <a:solidFill>
-                  <a:srgbClr val="5C4A3A"/>
-                </a:solidFill>
-                <a:latin typeface="DM Sans" pitchFamily="34" charset="0"/>
-                <a:ea typeface="DM Sans" pitchFamily="34" charset="-122"/>
-                <a:cs typeface="DM Sans" pitchFamily="34" charset="-120"/>
-              </a:rPr>
-              <a:t>fontide</a:t>
-            </a:r>
-            <a:r>
-              <a:rPr lang="en-US" sz="1800" dirty="0">
-                <a:solidFill>
-                  <a:srgbClr val="5C4A3A"/>
-                </a:solidFill>
-                <a:latin typeface="DM Sans" pitchFamily="34" charset="0"/>
-                <a:ea typeface="DM Sans" pitchFamily="34" charset="-122"/>
-                <a:cs typeface="DM Sans" pitchFamily="34" charset="-120"/>
-              </a:rPr>
-              <a:t> valik — tahtsin sooja, paberist päeviku tunnet</a:t>
-            </a:r>
             <a:endParaRPr lang="en-US" sz="1800" dirty="0"/>
           </a:p>
-          <a:p>
-            <a:pPr marL="228600" indent="-228600">
-              <a:lnSpc>
-                <a:spcPct val="130000"/>
-              </a:lnSpc>
-              <a:spcAft>
-                <a:spcPts val="1400"/>
-              </a:spcAft>
-              <a:buSzPct val="100000"/>
-              <a:buChar char="•"/>
-            </a:pPr>
-            <a:r>
-              <a:rPr lang="en-US" sz="1800" dirty="0">
-                <a:solidFill>
-                  <a:srgbClr val="5C4A3A"/>
-                </a:solidFill>
-                <a:latin typeface="DM Sans" pitchFamily="34" charset="0"/>
-                <a:ea typeface="DM Sans" pitchFamily="34" charset="-122"/>
-                <a:cs typeface="DM Sans" pitchFamily="34" charset="-120"/>
-              </a:rPr>
-              <a:t>Andmestruktuur — oskuste sõltuvuste graafiks tegemine oli loomulik</a:t>
-            </a:r>
-            <a:endParaRPr lang="en-US" sz="1800" dirty="0"/>
-          </a:p>
-          <a:p>
-            <a:pPr marL="228600" indent="-228600">
-              <a:lnSpc>
-                <a:spcPct val="130000"/>
-              </a:lnSpc>
-              <a:spcAft>
-                <a:spcPts val="1400"/>
-              </a:spcAft>
-              <a:buSzPct val="100000"/>
-              <a:buChar char="•"/>
-            </a:pPr>
-            <a:r>
-              <a:rPr lang="en-US" sz="1800" dirty="0">
-                <a:solidFill>
-                  <a:srgbClr val="5C4A3A"/>
-                </a:solidFill>
-                <a:latin typeface="DM Sans" pitchFamily="34" charset="0"/>
-                <a:ea typeface="DM Sans" pitchFamily="34" charset="-122"/>
-                <a:cs typeface="DM Sans" pitchFamily="34" charset="-120"/>
-              </a:rPr>
-              <a:t>Supabase autentimine — minimaalne kogus koodi, töötas esimese korraga</a:t>
-            </a:r>
-            <a:endParaRPr lang="en-US" sz="1800" dirty="0"/>
-          </a:p>
-          <a:p>
-            <a:pPr marL="228600" indent="-228600">
-              <a:lnSpc>
-                <a:spcPct val="130000"/>
-              </a:lnSpc>
-              <a:spcAft>
-                <a:spcPts val="1400"/>
-              </a:spcAft>
-              <a:buSzPct val="100000"/>
-              <a:buChar char="•"/>
-            </a:pPr>
-            <a:r>
-              <a:rPr lang="en-US" sz="1800" dirty="0">
-                <a:solidFill>
-                  <a:srgbClr val="5C4A3A"/>
-                </a:solidFill>
-                <a:latin typeface="DM Sans" pitchFamily="34" charset="0"/>
-                <a:ea typeface="DM Sans" pitchFamily="34" charset="-122"/>
-                <a:cs typeface="DM Sans" pitchFamily="34" charset="-120"/>
-              </a:rPr>
-              <a:t>Sõltumine olekust (XP → uinunud / paljas / kasvab / õitseb) — puhas funktsioon</a:t>
-            </a:r>
-            <a:endParaRPr lang="en-US" sz="1800" dirty="0"/>
-          </a:p>
-          <a:p>
-            <a:pPr marL="228600" indent="-228600">
-              <a:lnSpc>
-                <a:spcPct val="130000"/>
-              </a:lnSpc>
-              <a:spcAft>
-                <a:spcPts val="1400"/>
-              </a:spcAft>
-              <a:buSzPct val="100000"/>
-              <a:buChar char="•"/>
-            </a:pPr>
-            <a:r>
-              <a:rPr lang="en-US" sz="1800" dirty="0">
-                <a:solidFill>
-                  <a:srgbClr val="5C4A3A"/>
-                </a:solidFill>
-                <a:latin typeface="DM Sans" pitchFamily="34" charset="0"/>
-                <a:ea typeface="DM Sans" pitchFamily="34" charset="-122"/>
-                <a:cs typeface="DM Sans" pitchFamily="34" charset="-120"/>
-              </a:rPr>
-              <a:t>AI tööriistade koostöö — Claude Design visualiseeris, Claude Code rakendas</a:t>
-            </a:r>
-            <a:endParaRPr lang="en-US" sz="1800" dirty="0"/>
-          </a:p>
-        </p:txBody>
-      </p:sp>
+        </p:txBody>
+      </p:sp>
+      <p:pic>
+        <p:nvPicPr>
+          <p:cNvPr id="12" name="Picture 11">
+            <a:extLst>
+              <a:ext uri="{FF2B5EF4-FFF2-40B4-BE49-F238E27FC236}">
+                <a16:creationId xmlns:a16="http://schemas.microsoft.com/office/drawing/2014/main" id="{4979EA1F-2198-8D1F-7428-CA0C3A761960}"/>
+              </a:ext>
+            </a:extLst>
+          </p:cNvPr>
+          <p:cNvPicPr>
+            <a:picLocks noChangeAspect="1"/>
+          </p:cNvPicPr>
+          <p:nvPr/>
+        </p:nvPicPr>
+        <p:blipFill>
+          <a:blip r:embed="rId3"/>
+          <a:stretch>
+            <a:fillRect/>
+          </a:stretch>
+        </p:blipFill>
+        <p:spPr>
+          <a:xfrm>
+            <a:off x="72691" y="0"/>
+            <a:ext cx="12046618" cy="6858000"/>
+          </a:xfrm>
+          <a:prstGeom prst="rect">
+            <a:avLst/>
+          </a:prstGeom>
+        </p:spPr>
+      </p:pic>
     </p:spTree>
+    <p:extLst>
+      <p:ext uri="{BB962C8B-B14F-4D97-AF65-F5344CB8AC3E}">
+        <p14:creationId xmlns:p14="http://schemas.microsoft.com/office/powerpoint/2010/main" val="1113064152"/>
+      </p:ext>
+    </p:extLst>
   </p:cSld>
   <p:clrMapOvr>
     <a:masterClrMapping/>

</xml_diff>

<commit_message>
Update guitar tutorials and add deck patch / renumber scripts
- Swap four guitar tutorial URLs (Music Theory, Open Chords, Barre
  Chords, Songwriting) to YouTube videos and re-credit the actual
  creators (samuraiguitarist, Andy Guitar, JustinGuitar, Signals
  Music Studio)
- Generator: rasterize embedded SVG brand mark to PNG (Google Slides
  cannot render SVG-as-data-URI; PowerPoint's "Image could not be
  loaded" placeholder when uploaded)
- Add scripts/patch-brand-png.mjs: swap embedded SVG → PNG inside an
  existing .pptx without regenerating the deck. Collapses the
  asvg:svgBlip extension into a plain PNG a:blip and prunes the
  obsolete svg Default content-type entry
- Add scripts/renumber-presentation.mjs: walk slides in document order
  and rewrite "X / Y" page tags so they're sequential after manual
  insertions/deletions in PowerPoint
- Add jszip + sharp as dev deps for the patch tooling
</commit_message>
<xml_diff>
--- a/SkillTree-eksam.pptx
+++ b/SkillTree-eksam.pptx
@@ -1678,13 +1678,7 @@
           <p:nvPr/>
         </p:nvPicPr>
         <p:blipFill>
-          <a:blip>
-            <a:extLst>
-              <a:ext uri="{96DAC541-7B7A-43D3-8B79-37D633B846F1}">
-                <asvg:svgBlip xmlns:asvg="http://schemas.microsoft.com/office/drawing/2016/SVG/main" r:embed="rId3"/>
-              </a:ext>
-            </a:extLst>
-          </a:blip>
+          <a:blip r:embed="rId3"/>
           <a:stretch>
             <a:fillRect/>
           </a:stretch>

</xml_diff>